<commit_message>
docs: the progress deck, in English throughout
Slides and speaker notes rewritten in English; the numbers and their
sources are unchanged. Chip row on the state slide widened so the mono
tokens stop wrapping.

Co-Authored-By: Claude Opus 5 <noreply@anthropic.com>
Claude-Session: https://claude.ai/code/session_013CWef9zbtJr1JooRLX4aXK
</commit_message>
<xml_diff>
--- a/docs/slides/glyph-progress-2026-09-04.pptx
+++ b/docs/slides/glyph-progress-2026-09-04.pptx
@@ -135,7 +135,7 @@
               <c:strCache>
                 <c:ptCount val="1"/>
                 <c:pt idx="0">
-                  <c:v>overall（全部 500 题）</c:v>
+                  <c:v>overall (all 500 items)</c:v>
                 </c:pt>
               </c:strCache>
             </c:strRef>
@@ -181,10 +181,10 @@
                     <c:v>skeleton ceiling</c:v>
                   </c:pt>
                   <c:pt idx="1">
-                    <c:v>A0′ 前沿模型</c:v>
+                    <c:v>A0′ frontier</c:v>
                   </c:pt>
                   <c:pt idx="2">
-                    <c:v>weights 1.7B 学生</c:v>
+                    <c:v>weights 1.7B</c:v>
                   </c:pt>
                 </c:lvl>
               </c:multiLvlStrCache>
@@ -218,7 +218,7 @@
               <c:strCache>
                 <c:ptCount val="1"/>
                 <c:pt idx="0">
-                  <c:v>tail（必须外推的题）</c:v>
+                  <c:v>tail (items needing extrapolation)</c:v>
                 </c:pt>
               </c:strCache>
             </c:strRef>
@@ -264,10 +264,10 @@
                     <c:v>skeleton ceiling</c:v>
                   </c:pt>
                   <c:pt idx="1">
-                    <c:v>A0′ 前沿模型</c:v>
+                    <c:v>A0′ frontier</c:v>
                   </c:pt>
                   <c:pt idx="2">
-                    <c:v>weights 1.7B 学生</c:v>
+                    <c:v>weights 1.7B</c:v>
                   </c:pt>
                 </c:lvl>
               </c:multiLvlStrCache>
@@ -483,7 +483,7 @@
               <c:strCache>
                 <c:ptCount val="1"/>
                 <c:pt idx="0">
-                  <c:v>item score（全部题）</c:v>
+                  <c:v>item score (all items)</c:v>
                 </c:pt>
               </c:strCache>
             </c:strRef>
@@ -609,7 +609,7 @@
               <c:strCache>
                 <c:ptCount val="1"/>
                 <c:pt idx="0">
-                  <c:v>tail（必须外推的题）</c:v>
+                  <c:v>tail (items needing extrapolation)</c:v>
                 </c:pt>
               </c:strCache>
             </c:strRef>
@@ -1288,7 +1288,7 @@
           <a:p>
             <a:r>
               <a:rPr lang="en-US" dirty="0"/>
-              <a:t>Glyph 是 Phase 1 的 T1 任务：一个隐藏语义的 DSL 执行基准，用来测量能力应该放在 context / code / weights 哪一层。语法公开、语义私有。</a:t>
+              <a:t>Glyph is task T1 of the Phase 1 plan: a hidden-semantics DSL execution benchmark for measuring whether capability belongs in context, in code, or in weights. The syntax is public; the semantics are private.</a:t>
             </a:r>
             <a:endParaRPr lang="en-US" dirty="0"/>
           </a:p>
@@ -1376,7 +1376,7 @@
           <a:p>
             <a:r>
               <a:rPr lang="en-US" dirty="0"/>
-              <a:t>π 的分子是 L_skel。翻过来的话相图会整个反向而曲线照样画得出来 —— 这是会静默失败的两件事之一。另一件是 trivial skeleton 必须仍然调用表。</a:t>
+              <a:t>π's numerator is L_skel. Flip it and the phase diagram runs backwards while the curves still plot — one of the two things here that fail silently. The other is the trivial skeleton, which must still invoke the tables.</a:t>
             </a:r>
             <a:endParaRPr lang="en-US" dirty="0"/>
           </a:p>
@@ -1464,7 +1464,7 @@
           <a:p>
             <a:r>
               <a:rPr lang="en-US" dirty="0"/>
-              <a:t>Q≈2000 对 |V|=4913：unary 表最多覆盖一半，binary 表 24M 条基本为零。没有 floor 分片，测试集完全可解，ceiling 是干净的 100%。</a:t>
+              <a:t>Q ≈ 2000 against |V| = 4913 means the unary tables are at best half covered and the binary tables essentially not at all. There is no floor split: the test set is fully solvable and the ceiling is a clean 100%.</a:t>
             </a:r>
             <a:endParaRPr lang="en-US" dirty="0"/>
           </a:p>
@@ -1552,7 +1552,7 @@
           <a:p>
             <a:r>
               <a:rPr lang="en-US" dirty="0"/>
-              <a:t>tail 这一列是 2026-09-03 才补上的，补上之前只有 overall，还可以辩解成 A0′ 只是在简单题上做得差。补上之后这个读法就没有了。</a:t>
+              <a:t>The tail column was only added on 2026-09-03. Before it, the overall scores still allowed the reading that A0' had merely done worse on the easy items. The tail column removes that reading.</a:t>
             </a:r>
             <a:endParaRPr lang="en-US" dirty="0"/>
           </a:p>
@@ -1640,7 +1640,7 @@
           <a:p>
             <a:r>
               <a:rPr lang="en-US" dirty="0"/>
-              <a:t>这条同时也确认了数据层的地基：π→0 那一端假设表是「学得会但读不出来」的，A0′ 从部分观测里失败正是对它的直接检验，通过了，所以冻结不用重开。</a:t>
+              <a:t>This also confirms the data layer's foundation. The pi-to-zero end assumes the tables are learnable but not in-context-extractable; A0' failing from partial observation is the direct test of that, and it passed, so the freeze does not have to be reopened.</a:t>
             </a:r>
             <a:endParaRPr lang="en-US" dirty="0"/>
           </a:p>
@@ -1728,7 +1728,7 @@
           <a:p>
             <a:r>
               <a:rPr lang="en-US" dirty="0"/>
-              <a:t>可测带 [0.248, 0.498]：25 个点，对着 #9 说的 arm 之间 1-3 点的差距是够宽的。depth 分片塌得最快，0.817 → 0.217，因为它每题查表次数最多。</a:t>
+              <a:t>25 points of band is wide against the 1-3 point differences the arms are expected to be separated by. depth collapses fastest, 0.817 to 0.217, because it has the most lookups per item.</a:t>
             </a:r>
             <a:endParaRPr lang="en-US" dirty="0"/>
           </a:p>
@@ -1816,7 +1816,7 @@
           <a:p>
             <a:r>
               <a:rPr lang="en-US" dirty="0"/>
-              <a:t>HANDOFF.md 里「36 tests」那一行已经过时，当前是 138。#4 hiddenness 因为每个 preset 都换过必须重跑，上次全量跑约 110 分钟。</a:t>
+              <a:t>HANDOFF.md still says 36 tests; the current figure is 138. Self-check #4 must be rerun because every preset changed — the last full run took about 110 minutes and costs teacher calls.</a:t>
             </a:r>
             <a:endParaRPr lang="en-US" dirty="0"/>
           </a:p>
@@ -1904,7 +1904,7 @@
           <a:p>
             <a:r>
               <a:rPr lang="en-US" dirty="0"/>
-              <a:t>顺序来自 open_questions.md 的 Order 段：E0 已经作废两次，#1 #5 #6 #7 #8 里任何一个再动都会是第三次。</a:t>
+              <a:t>The order comes from the Order section of open_questions.md. E0 has been invalidated twice already; any of #1, #5, #6, #7, #8 moving again would make it three times.</a:t>
             </a:r>
             <a:endParaRPr lang="en-US" dirty="0"/>
           </a:p>
@@ -2403,7 +2403,7 @@
         <p:spPr>
           <a:xfrm>
             <a:off x="640080" y="2121408"/>
-            <a:ext cx="8229600" cy="457200"/>
+            <a:ext cx="8778240" cy="457200"/>
           </a:xfrm>
           <a:prstGeom prst="rect">
             <a:avLst/>
@@ -2427,7 +2427,7 @@
                 <a:ea typeface="Calibri" pitchFamily="34" charset="-122"/>
                 <a:cs typeface="Calibri" pitchFamily="34" charset="-120"/>
               </a:rPr>
-              <a:t>隐藏语义 DSL 执行基准 —— 项目进展</a:t>
+              <a:t>A hidden-semantics DSL execution benchmark</a:t>
             </a:r>
             <a:endParaRPr lang="en-US" sz="2200" dirty="0"/>
           </a:p>
@@ -2441,20 +2441,23 @@
         </p:nvSpPr>
         <p:spPr>
           <a:xfrm>
-            <a:off x="640080" y="2633472"/>
-            <a:ext cx="8778240" cy="365760"/>
-          </a:xfrm>
-          <a:prstGeom prst="rect">
-            <a:avLst/>
-          </a:prstGeom>
-          <a:noFill/>
-          <a:ln/>
-        </p:spPr>
-        <p:txBody>
-          <a:bodyPr wrap="square" lIns="0" tIns="0" rIns="0" bIns="0" rtlCol="0" anchor="ctr"/>
-          <a:lstStyle/>
-          <a:p>
-            <a:pPr indent="0" marL="0">
+            <a:off x="640080" y="2606040"/>
+            <a:ext cx="9509760" cy="594360"/>
+          </a:xfrm>
+          <a:prstGeom prst="rect">
+            <a:avLst/>
+          </a:prstGeom>
+          <a:noFill/>
+          <a:ln/>
+        </p:spPr>
+        <p:txBody>
+          <a:bodyPr wrap="square" lIns="0" tIns="0" rIns="0" bIns="0" rtlCol="0" anchor="ctr"/>
+          <a:lstStyle/>
+          <a:p>
+            <a:pPr indent="0" marL="0">
+              <a:lnSpc>
+                <a:spcPct val="120000"/>
+              </a:lnSpc>
               <a:buNone/>
             </a:pPr>
             <a:r>
@@ -2466,7 +2469,7 @@
                 <a:ea typeface="Calibri" pitchFamily="34" charset="-122"/>
                 <a:cs typeface="Calibri" pitchFamily="34" charset="-120"/>
               </a:rPr>
-              <a:t>能力该放进 context、code，还是一个小模型的 weights？这个仓库是把问题变成可测量的那把尺。</a:t>
+              <a:t>Does capability pay to sit in context, in code, or in a small model's weights — and does the agent know which? This repo is the ruler that makes the question measurable.</a:t>
             </a:r>
             <a:endParaRPr lang="en-US" sz="1400" dirty="0"/>
           </a:p>
@@ -2571,7 +2574,7 @@
                 <a:ea typeface="Calibri" pitchFamily="34" charset="-122"/>
                 <a:cs typeface="Calibri" pitchFamily="34" charset="-120"/>
               </a:rPr>
-              <a:t>算子名字是刻意不可读的：只有 s0 / u2 / b0，永远不会是 map / fold —— 命名先验不许泄漏任何语义。</a:t>
+              <a:t>Operator names are deliberately opaque — s0 / u2 / b0, never map / fold — so naming priors leak nothing.</a:t>
             </a:r>
             <a:endParaRPr lang="en-US" sz="1250" dirty="0"/>
           </a:p>
@@ -2610,7 +2613,7 @@
                 <a:ea typeface="Calibri" pitchFamily="34" charset="-122"/>
                 <a:cs typeface="Calibri" pitchFamily="34" charset="-120"/>
               </a:rPr>
-              <a:t>数据层已冻结</a:t>
+              <a:t>Data layer frozen</a:t>
             </a:r>
             <a:endParaRPr lang="en-US" sz="1200" dirty="0"/>
           </a:p>
@@ -2688,7 +2691,7 @@
                 <a:ea typeface="Calibri" pitchFamily="34" charset="-122"/>
                 <a:cs typeface="Calibri" pitchFamily="34" charset="-120"/>
               </a:rPr>
-              <a:t>测试全绿</a:t>
+              <a:t>Test suite</a:t>
             </a:r>
             <a:endParaRPr lang="en-US" sz="1200" dirty="0"/>
           </a:p>
@@ -2766,7 +2769,7 @@
                 <a:ea typeface="Calibri" pitchFamily="34" charset="-122"/>
                 <a:cs typeface="Calibri" pitchFamily="34" charset="-120"/>
               </a:rPr>
-              <a:t>首个三方结果</a:t>
+              <a:t>First three-way result</a:t>
             </a:r>
             <a:endParaRPr lang="en-US" sz="1200" dirty="0"/>
           </a:p>
@@ -2805,7 +2808,7 @@
                 <a:ea typeface="Courier New" pitchFamily="34" charset="-122"/>
                 <a:cs typeface="Courier New" pitchFamily="34" charset="-120"/>
               </a:rPr>
-              <a:t>已出，见第 4 页</a:t>
+              <a:t>in — see page 4</a:t>
             </a:r>
             <a:endParaRPr lang="en-US" sz="1700" dirty="0"/>
           </a:p>
@@ -2993,7 +2996,7 @@
                 <a:ea typeface="Cambria" pitchFamily="34" charset="-122"/>
                 <a:cs typeface="Cambria" pitchFamily="34" charset="-120"/>
               </a:rPr>
-              <a:t>语法公开，语义私有 —— 而私有的部分正好分成两半</a:t>
+              <a:t>Syntax public, semantics private — split in two</a:t>
             </a:r>
             <a:endParaRPr lang="en-US" sz="3000" dirty="0"/>
           </a:p>
@@ -3125,7 +3128,7 @@
                 <a:ea typeface="Calibri" pitchFamily="34" charset="-122"/>
                 <a:cs typeface="Calibri" pitchFamily="34" charset="-120"/>
               </a:rPr>
-              <a:t>结构算子的语义</a:t>
+              <a:t>The semantics of the structural operators</a:t>
             </a:r>
             <a:endParaRPr lang="en-US" sz="1500" dirty="0"/>
           </a:p>
@@ -3140,7 +3143,7 @@
         <p:spPr>
           <a:xfrm>
             <a:off x="960120" y="2606040"/>
-            <a:ext cx="4480560" cy="1005840"/>
+            <a:ext cx="4480560" cy="1051560"/>
           </a:xfrm>
           <a:prstGeom prst="rect">
             <a:avLst/>
@@ -3167,7 +3170,7 @@
                 <a:ea typeface="Calibri" pitchFamily="34" charset="-122"/>
                 <a:cs typeface="Calibri" pitchFamily="34" charset="-120"/>
               </a:rPr>
-              <a:t>来自：</a:t>
+              <a:t>Where it comes from:  </a:t>
             </a:r>
             <a:pPr indent="0" marL="0">
               <a:lnSpc>
@@ -3184,7 +3187,7 @@
                 <a:ea typeface="Calibri" pitchFamily="34" charset="-122"/>
                 <a:cs typeface="Calibri" pitchFamily="34" charset="-120"/>
               </a:rPr>
-              <a:t>从一个有限组合子文法里抽出来</a:t>
+              <a:t>sampled from a finite combinator grammar</a:t>
             </a:r>
             <a:endParaRPr lang="en-US" sz="1350" dirty="0"/>
           </a:p>
@@ -3204,7 +3207,7 @@
                 <a:ea typeface="Calibri" pitchFamily="34" charset="-122"/>
                 <a:cs typeface="Calibri" pitchFamily="34" charset="-120"/>
               </a:rPr>
-              <a:t>能不能写下来：</a:t>
+              <a:t>Can you write it down:  </a:t>
             </a:r>
             <a:pPr indent="0" marL="0">
               <a:lnSpc>
@@ -3221,7 +3224,7 @@
                 <a:ea typeface="Calibri" pitchFamily="34" charset="-122"/>
                 <a:cs typeface="Calibri" pitchFamily="34" charset="-120"/>
               </a:rPr>
-              <a:t>能 —— 有限条规则，按构造就是可枚举的</a:t>
+              <a:t>Yes — finitely many rules, by construction</a:t>
             </a:r>
             <a:endParaRPr lang="en-US" sz="1350" dirty="0"/>
           </a:p>
@@ -3260,7 +3263,7 @@
                 <a:ea typeface="Cambria" pitchFamily="34" charset="-122"/>
                 <a:cs typeface="Cambria" pitchFamily="34" charset="-120"/>
               </a:rPr>
-              <a:t>code 的主场</a:t>
+              <a:t>code's home ground</a:t>
             </a:r>
             <a:endParaRPr lang="en-US" sz="1800" dirty="0"/>
           </a:p>
@@ -3392,7 +3395,7 @@
                 <a:ea typeface="Calibri" pitchFamily="34" charset="-122"/>
                 <a:cs typeface="Calibri" pitchFamily="34" charset="-120"/>
               </a:rPr>
-              <a:t>原子算子的语义</a:t>
+              <a:t>The semantics of the atomic operators</a:t>
             </a:r>
             <a:endParaRPr lang="en-US" sz="1500" dirty="0"/>
           </a:p>
@@ -3407,7 +3410,7 @@
         <p:spPr>
           <a:xfrm>
             <a:off x="6748272" y="2606040"/>
-            <a:ext cx="4480560" cy="1005840"/>
+            <a:ext cx="4480560" cy="1051560"/>
           </a:xfrm>
           <a:prstGeom prst="rect">
             <a:avLst/>
@@ -3434,7 +3437,7 @@
                 <a:ea typeface="Calibri" pitchFamily="34" charset="-122"/>
                 <a:cs typeface="Calibri" pitchFamily="34" charset="-120"/>
               </a:rPr>
-              <a:t>来自：</a:t>
+              <a:t>Where it comes from:  </a:t>
             </a:r>
             <a:pPr indent="0" marL="0">
               <a:lnSpc>
@@ -3451,7 +3454,7 @@
                 <a:ea typeface="Calibri" pitchFamily="34" charset="-122"/>
                 <a:cs typeface="Calibri" pitchFamily="34" charset="-120"/>
               </a:rPr>
-              <a:t>digit embedding + 冻结的随机 MLP</a:t>
+              <a:t>digit embeddings + frozen random MLPs</a:t>
             </a:r>
             <a:endParaRPr lang="en-US" sz="1350" dirty="0"/>
           </a:p>
@@ -3471,7 +3474,7 @@
                 <a:ea typeface="Calibri" pitchFamily="34" charset="-122"/>
                 <a:cs typeface="Calibri" pitchFamily="34" charset="-120"/>
               </a:rPr>
-              <a:t>能不能写下来：</a:t>
+              <a:t>Can you write it down:  </a:t>
             </a:r>
             <a:pPr indent="0" marL="0">
               <a:lnSpc>
@@ -3488,7 +3491,7 @@
                 <a:ea typeface="Calibri" pitchFamily="34" charset="-122"/>
                 <a:cs typeface="Calibri" pitchFamily="34" charset="-120"/>
               </a:rPr>
-              <a:t>不能 —— 写下来等于在抄权重矩阵</a:t>
+              <a:t>No — you would be transcribing weight matrices</a:t>
             </a:r>
             <a:endParaRPr lang="en-US" sz="1350" dirty="0"/>
           </a:p>
@@ -3527,7 +3530,7 @@
                 <a:ea typeface="Cambria" pitchFamily="34" charset="-122"/>
                 <a:cs typeface="Cambria" pitchFamily="34" charset="-120"/>
               </a:rPr>
-              <a:t>weights 的主场</a:t>
+              <a:t>weights' home ground</a:t>
             </a:r>
             <a:endParaRPr lang="en-US" sz="1800" dirty="0"/>
           </a:p>
@@ -3608,19 +3611,22 @@
         <p:spPr>
           <a:xfrm>
             <a:off x="1005840" y="5120640"/>
-            <a:ext cx="5486400" cy="640080"/>
-          </a:xfrm>
-          <a:prstGeom prst="rect">
-            <a:avLst/>
-          </a:prstGeom>
-          <a:noFill/>
-          <a:ln/>
-        </p:spPr>
-        <p:txBody>
-          <a:bodyPr wrap="square" lIns="0" tIns="0" rIns="0" bIns="0" rtlCol="0" anchor="ctr"/>
-          <a:lstStyle/>
-          <a:p>
-            <a:pPr indent="0" marL="0">
+            <a:ext cx="5486400" cy="731520"/>
+          </a:xfrm>
+          <a:prstGeom prst="rect">
+            <a:avLst/>
+          </a:prstGeom>
+          <a:noFill/>
+          <a:ln/>
+        </p:spPr>
+        <p:txBody>
+          <a:bodyPr wrap="square" lIns="0" tIns="0" rIns="0" bIns="0" rtlCol="0" anchor="ctr"/>
+          <a:lstStyle/>
+          <a:p>
+            <a:pPr indent="0" marL="0">
+              <a:lnSpc>
+                <a:spcPct val="120000"/>
+              </a:lnSpc>
               <a:buNone/>
             </a:pPr>
             <a:r>
@@ -3632,7 +3638,7 @@
                 <a:ea typeface="Calibri" pitchFamily="34" charset="-122"/>
                 <a:cs typeface="Calibri" pitchFamily="34" charset="-120"/>
               </a:rPr>
-              <a:t>难度里属于 skeleton 的那一半。π→1 该 code 赢，π→0 该 weights 赢。</a:t>
+              <a:t>The skeleton's share of the difficulty. π → 1 means code should win; π → 0 means weights should win.</a:t>
             </a:r>
             <a:endParaRPr lang="en-US" sz="1350" dirty="0"/>
           </a:p>
@@ -3647,7 +3653,7 @@
         <p:spPr>
           <a:xfrm>
             <a:off x="6492240" y="4709160"/>
-            <a:ext cx="4937760" cy="1143000"/>
+            <a:ext cx="4937760" cy="1188720"/>
           </a:xfrm>
           <a:prstGeom prst="rect">
             <a:avLst/>
@@ -3674,7 +3680,7 @@
                 <a:ea typeface="Calibri" pitchFamily="34" charset="-122"/>
                 <a:cs typeface="Calibri" pitchFamily="34" charset="-120"/>
               </a:rPr>
-              <a:t>π 是每个实例测出来的，不是配置出来的。</a:t>
+              <a:t>π is measured per instance, never configured.</a:t>
             </a:r>
             <a:endParaRPr lang="en-US" sz="1300" dirty="0"/>
           </a:p>
@@ -3694,7 +3700,7 @@
                 <a:ea typeface="Calibri" pitchFamily="34" charset="-122"/>
                 <a:cs typeface="Calibri" pitchFamily="34" charset="-120"/>
               </a:rPr>
-              <a:t>preset 只是采样器：20 个 pi_mid 种子里有 7 个落在 pi_high 的区间内，所以相图的横轴用 measured_pi()，永远不用 preset 名字。</a:t>
+              <a:t>A preset is only a sampler: 7 of 20 pi_mid seeds land inside pi_high's measured range, so phase-diagram axes use measured_pi(), never a preset name.</a:t>
             </a:r>
             <a:endParaRPr lang="en-US" sz="1300" dirty="0"/>
           </a:p>
@@ -3843,7 +3849,7 @@
                 <a:ea typeface="Cambria" pitchFamily="34" charset="-122"/>
                 <a:cs typeface="Cambria" pitchFamily="34" charset="-120"/>
               </a:rPr>
-              <a:t>Agent 的处境：可以买，但买不完</a:t>
+              <a:t>The agent can buy, but never buy enough</a:t>
             </a:r>
             <a:endParaRPr lang="en-US" sz="3000" dirty="0"/>
           </a:p>
@@ -3948,7 +3954,7 @@
                 <a:ea typeface="Calibri" pitchFamily="34" charset="-122"/>
                 <a:cs typeface="Calibri" pitchFamily="34" charset="-120"/>
               </a:rPr>
-              <a:t>免费拿到</a:t>
+              <a:t>Free of charge</a:t>
             </a:r>
             <a:endParaRPr lang="en-US" sz="1600" dirty="0"/>
           </a:p>
@@ -3990,7 +3996,7 @@
                 <a:ea typeface="Calibri" pitchFamily="34" charset="-122"/>
                 <a:cs typeface="Calibri" pitchFamily="34" charset="-120"/>
               </a:rPr>
-              <a:t>语法 spec + 30 个 demo。仅此而已。</a:t>
+              <a:t>The syntax spec and 30 demos. That is all it starts with.</a:t>
             </a:r>
             <a:endParaRPr lang="en-US" sz="1300" dirty="0"/>
           </a:p>
@@ -4095,7 +4101,7 @@
                 <a:ea typeface="Calibri" pitchFamily="34" charset="-122"/>
                 <a:cs typeface="Calibri" pitchFamily="34" charset="-120"/>
               </a:rPr>
-              <a:t>计费查询</a:t>
+              <a:t>Metered queries</a:t>
             </a:r>
             <a:endParaRPr lang="en-US" sz="1600" dirty="0"/>
           </a:p>
@@ -4137,7 +4143,7 @@
                 <a:ea typeface="Calibri" pitchFamily="34" charset="-122"/>
                 <a:cs typeface="Calibri" pitchFamily="34" charset="-120"/>
               </a:rPr>
-              <a:t>可以拿任意合法表达式去问 P，每次都扣预算 —— 语法错误也扣，探文法不是免费的。ledger 是唯一能推进时钟的入口。</a:t>
+              <a:t>It may ask P about any well-formed expression, and every query costs budget — syntax errors included, so probing the grammar is not free. The ledger is the only way to advance the clock.</a:t>
             </a:r>
             <a:endParaRPr lang="en-US" sz="1300" dirty="0"/>
           </a:p>
@@ -4242,7 +4248,7 @@
                 <a:ea typeface="Calibri" pitchFamily="34" charset="-122"/>
                 <a:cs typeface="Calibri" pitchFamily="34" charset="-120"/>
               </a:rPr>
-              <a:t>封存作答</a:t>
+              <a:t>Seal, then answer</a:t>
             </a:r>
             <a:endParaRPr lang="en-US" sz="1600" dirty="0"/>
           </a:p>
@@ -4284,7 +4290,7 @@
                 <a:ea typeface="Calibri" pitchFamily="34" charset="-122"/>
                 <a:cs typeface="Calibri" pitchFamily="34" charset="-120"/>
               </a:rPr>
-              <a:t>交出一个 artifact，回答 10,000 道没见过的题，此后不再接触 P。</a:t>
+              <a:t>It seals an artifact that must answer 10,000 unseen expressions, with no further access to P.</a:t>
             </a:r>
             <a:endParaRPr lang="en-US" sz="1300" dirty="0"/>
           </a:p>
@@ -4365,7 +4371,7 @@
         <p:spPr>
           <a:xfrm>
             <a:off x="7114032" y="2176272"/>
-            <a:ext cx="1865376" cy="548640"/>
+            <a:ext cx="1865376" cy="566928"/>
           </a:xfrm>
           <a:prstGeom prst="rect">
             <a:avLst/>
@@ -4392,7 +4398,7 @@
                 <a:ea typeface="Calibri" pitchFamily="34" charset="-122"/>
                 <a:cs typeface="Calibri" pitchFamily="34" charset="-120"/>
               </a:rPr>
-              <a:t>一次运行买得起的查询数</a:t>
+              <a:t>queries a run can afford</a:t>
             </a:r>
             <a:endParaRPr lang="en-US" sz="1150" dirty="0"/>
           </a:p>
@@ -4473,7 +4479,7 @@
         <p:spPr>
           <a:xfrm>
             <a:off x="9518904" y="2176272"/>
-            <a:ext cx="1865376" cy="548640"/>
+            <a:ext cx="1865376" cy="566928"/>
           </a:xfrm>
           <a:prstGeom prst="rect">
             <a:avLst/>
@@ -4500,7 +4506,7 @@
                 <a:ea typeface="Calibri" pitchFamily="34" charset="-122"/>
                 <a:cs typeface="Calibri" pitchFamily="34" charset="-120"/>
               </a:rPr>
-              <a:t>值空间 17³ · unary 表最多买到一半</a:t>
+              <a:t>value space 17³ · unary half-covered at best</a:t>
             </a:r>
             <a:endParaRPr lang="en-US" sz="1150" dirty="0"/>
           </a:p>
@@ -4581,7 +4587,7 @@
         <p:spPr>
           <a:xfrm>
             <a:off x="7114032" y="3639312"/>
-            <a:ext cx="1865376" cy="548640"/>
+            <a:ext cx="1865376" cy="566928"/>
           </a:xfrm>
           <a:prstGeom prst="rect">
             <a:avLst/>
@@ -4608,7 +4614,7 @@
                 <a:ea typeface="Calibri" pitchFamily="34" charset="-122"/>
                 <a:cs typeface="Calibri" pitchFamily="34" charset="-120"/>
               </a:rPr>
-              <a:t>binary 表的条目数 · 基本买不到</a:t>
+              <a:t>binary pairs · essentially untouchable</a:t>
             </a:r>
             <a:endParaRPr lang="en-US" sz="1150" dirty="0"/>
           </a:p>
@@ -4689,7 +4695,7 @@
         <p:spPr>
           <a:xfrm>
             <a:off x="9518904" y="3639312"/>
-            <a:ext cx="1865376" cy="548640"/>
+            <a:ext cx="1865376" cy="566928"/>
           </a:xfrm>
           <a:prstGeom prst="rect">
             <a:avLst/>
@@ -4716,7 +4722,7 @@
                 <a:ea typeface="Calibri" pitchFamily="34" charset="-122"/>
                 <a:cs typeface="Calibri" pitchFamily="34" charset="-120"/>
               </a:rPr>
-              <a:t>封存后要答的题</a:t>
+              <a:t>expressions to answer after the seal</a:t>
             </a:r>
             <a:endParaRPr lang="en-US" sz="1150" dirty="0"/>
           </a:p>
@@ -4758,7 +4764,7 @@
                 <a:ea typeface="Calibri" pitchFamily="34" charset="-122"/>
                 <a:cs typeface="Calibri" pitchFamily="34" charset="-120"/>
               </a:rPr>
-              <a:t>这个缺口就是「拟合能赢查表」的全部理由。</a:t>
+              <a:t>That gap is why fitting can beat looking things up.</a:t>
             </a:r>
             <a:pPr indent="0" marL="0">
               <a:lnSpc>
@@ -4775,7 +4781,7 @@
                 <a:ea typeface="Calibri" pitchFamily="34" charset="-122"/>
                 <a:cs typeface="Calibri" pitchFamily="34" charset="-120"/>
               </a:rPr>
-              <a:t>  分片：iid / comp / depth 在生成时固定；tail 每次运行现推 —— 这个 run 从没买过其表项的那些题，它同时也是对查询策略聪不聪明的读数。</a:t>
+              <a:t>  Splits: iid / comp / depth are fixed at generation; tail is derived per run — the items whose entries this run never bought, which doubles as a read on how smart its query strategy was.</a:t>
             </a:r>
             <a:endParaRPr lang="en-US" sz="1300" dirty="0"/>
           </a:p>
@@ -4885,7 +4891,7 @@
                 <a:ea typeface="Courier New" pitchFamily="34" charset="-122"/>
                 <a:cs typeface="Courier New" pitchFamily="34" charset="-120"/>
               </a:rPr>
-              <a:t>RESULT  ·  pi_mid / seed 1001 / 同一批分层抽样 500 题</a:t>
+              <a:t>RESULT  ·  pi_mid / seed 1001 / one stratified 500-item subset</a:t>
             </a:r>
             <a:endParaRPr lang="en-US" sz="1100" dirty="0"/>
           </a:p>
@@ -4924,7 +4930,7 @@
                 <a:ea typeface="Cambria" pitchFamily="34" charset="-122"/>
                 <a:cs typeface="Cambria" pitchFamily="34" charset="-120"/>
               </a:rPr>
-              <a:t>三方对照：前沿模型输给了一个 1.7B 学生</a:t>
+              <a:t>The frontier model loses to a 1.7B student</a:t>
             </a:r>
             <a:endParaRPr lang="en-US" sz="3000" dirty="0"/>
           </a:p>
@@ -4954,7 +4960,7 @@
         </p:nvSpPr>
         <p:spPr>
           <a:xfrm>
-            <a:off x="566928" y="5833872"/>
+            <a:off x="566928" y="5797296"/>
             <a:ext cx="6858000" cy="457200"/>
           </a:xfrm>
           <a:prstGeom prst="rect">
@@ -4982,7 +4988,7 @@
                 <a:ea typeface="Calibri" pitchFamily="34" charset="-122"/>
                 <a:cs typeface="Calibri" pitchFamily="34" charset="-120"/>
               </a:rPr>
-              <a:t>skeleton ceiling：完全不知道任何一条表项，只知道全部结构规则  ·  A0′：2551 条表项在 context 里，思考不限  ·  weights：1.7B，训练时见过 491 条</a:t>
+              <a:t>skeleton ceiling: every structural rule, not one table entry  ·  A0′: 2551 of 4913 entries in context, unlimited thinking  ·  weights: 1.7B, trained on 491 entries</a:t>
             </a:r>
             <a:endParaRPr lang="en-US" sz="1050" dirty="0"/>
           </a:p>
@@ -4997,7 +5003,7 @@
         <p:spPr>
           <a:xfrm>
             <a:off x="7726680" y="1691640"/>
-            <a:ext cx="3840480" cy="914400"/>
+            <a:ext cx="3840480" cy="1005840"/>
           </a:xfrm>
           <a:prstGeom prst="rect">
             <a:avLst/>
@@ -5024,7 +5030,7 @@
                 <a:ea typeface="Calibri" pitchFamily="34" charset="-122"/>
                 <a:cs typeface="Calibri" pitchFamily="34" charset="-120"/>
               </a:rPr>
-              <a:t>前沿模型被交到手里的表项是学生的 5 倍，参数是它的几百倍，思考不限时长 —— 总分低 24 个点。</a:t>
+              <a:t>The frontier was handed five times the table the student had, is hundreds of times larger, and thought without limit — and scores 24 points lower.</a:t>
             </a:r>
             <a:endParaRPr lang="en-US" sz="1400" dirty="0"/>
           </a:p>
@@ -5038,12 +5044,12 @@
         </p:nvSpPr>
         <p:spPr>
           <a:xfrm>
-            <a:off x="7726680" y="2743200"/>
-            <a:ext cx="3840480" cy="1600200"/>
+            <a:off x="7726680" y="2834640"/>
+            <a:ext cx="3840480" cy="1554480"/>
           </a:xfrm>
           <a:prstGeom prst="roundRect">
             <a:avLst>
-              <a:gd name="adj" fmla="val 1714"/>
+              <a:gd name="adj" fmla="val 1765"/>
             </a:avLst>
           </a:prstGeom>
           <a:solidFill>
@@ -5065,7 +5071,7 @@
         </p:nvSpPr>
         <p:spPr>
           <a:xfrm>
-            <a:off x="8001000" y="2880360"/>
+            <a:off x="8001000" y="2971800"/>
             <a:ext cx="3291840" cy="640080"/>
           </a:xfrm>
           <a:prstGeom prst="rect">
@@ -5104,8 +5110,8 @@
         </p:nvSpPr>
         <p:spPr>
           <a:xfrm>
-            <a:off x="8001000" y="3520440"/>
-            <a:ext cx="3291840" cy="777240"/>
+            <a:off x="8001000" y="3611880"/>
+            <a:ext cx="3291840" cy="731520"/>
           </a:xfrm>
           <a:prstGeom prst="rect">
             <a:avLst/>
@@ -5132,7 +5138,7 @@
                 <a:ea typeface="Calibri" pitchFamily="34" charset="-122"/>
                 <a:cs typeface="Calibri" pitchFamily="34" charset="-120"/>
               </a:rPr>
-              <a:t>在必须外推到「从没被给过的表项」的那批题上（374 对 372 题，两边几乎是同一批），1.7B 学生比前沿模型高二十倍。</a:t>
+              <a:t>On items needing entries never supplied — 374 against 372, nearly the same items — the 1.7B student beats the frontier twentyfold.</a:t>
             </a:r>
             <a:endParaRPr lang="en-US" sz="1200" dirty="0"/>
           </a:p>
@@ -5174,7 +5180,7 @@
                 <a:ea typeface="Calibri" pitchFamily="34" charset="-122"/>
                 <a:cs typeface="Calibri" pitchFamily="34" charset="-120"/>
               </a:rPr>
-              <a:t>tail 上 skeleton ceiling 是 0.000 —— 那批题没有一道能靠结构答出来，所以每一分都是表知识。</a:t>
+              <a:t>The skeleton ceiling on tail is 0.000 — nothing in there is answerable from structure, so every point is table knowledge.</a:t>
             </a:r>
             <a:endParaRPr lang="en-US" sz="1200" dirty="0"/>
           </a:p>
@@ -5323,7 +5329,7 @@
                 <a:ea typeface="Cambria" pitchFamily="34" charset="-122"/>
                 <a:cs typeface="Cambria" pitchFamily="34" charset="-120"/>
               </a:rPr>
-              <a:t>不是能力不够 —— 是两种能力被干净地切开了</a:t>
+              <a:t>Not a shortfall — two capabilities, cleanly split</a:t>
             </a:r>
             <a:endParaRPr lang="en-US" sz="3000" dirty="0"/>
           </a:p>
@@ -5389,7 +5395,7 @@
                 <a:ea typeface="Courier New" pitchFamily="34" charset="-122"/>
                 <a:cs typeface="Courier New" pitchFamily="34" charset="-120"/>
               </a:rPr>
-              <a:t>检索：饱和</a:t>
+              <a:t>Retrieval: saturated</a:t>
             </a:r>
             <a:endParaRPr lang="en-US" sz="1200" dirty="0"/>
           </a:p>
@@ -5442,8 +5448,8 @@
         </p:nvSpPr>
         <p:spPr>
           <a:xfrm>
-            <a:off x="3291840" y="2240280"/>
-            <a:ext cx="2240280" cy="822960"/>
+            <a:off x="3291840" y="2194560"/>
+            <a:ext cx="2240280" cy="914400"/>
           </a:xfrm>
           <a:prstGeom prst="rect">
             <a:avLst/>
@@ -5470,7 +5476,7 @@
                 <a:ea typeface="Calibri" pitchFamily="34" charset="-122"/>
                 <a:cs typeface="Calibri" pitchFamily="34" charset="-120"/>
               </a:rPr>
-              <a:t>126 题</a:t>
+              <a:t>126 items</a:t>
             </a:r>
             <a:endParaRPr lang="en-US" sz="1300" dirty="0"/>
           </a:p>
@@ -5490,7 +5496,7 @@
                 <a:ea typeface="Calibri" pitchFamily="34" charset="-122"/>
                 <a:cs typeface="Calibri" pitchFamily="34" charset="-120"/>
               </a:rPr>
-              <a:t>所需表项就在给它的证据里</a:t>
+              <a:t>needed entries were in the evidence</a:t>
             </a:r>
             <a:endParaRPr lang="en-US" sz="1300" dirty="0"/>
           </a:p>
@@ -5556,7 +5562,7 @@
                 <a:ea typeface="Courier New" pitchFamily="34" charset="-122"/>
                 <a:cs typeface="Courier New" pitchFamily="34" charset="-120"/>
               </a:rPr>
-              <a:t>外推：为零</a:t>
+              <a:t>Extrapolation: zero</a:t>
             </a:r>
             <a:endParaRPr lang="en-US" sz="1200" dirty="0"/>
           </a:p>
@@ -5609,8 +5615,8 @@
         </p:nvSpPr>
         <p:spPr>
           <a:xfrm>
-            <a:off x="9079992" y="2240280"/>
-            <a:ext cx="2240280" cy="822960"/>
+            <a:off x="9079992" y="2194560"/>
+            <a:ext cx="2240280" cy="914400"/>
           </a:xfrm>
           <a:prstGeom prst="rect">
             <a:avLst/>
@@ -5637,7 +5643,7 @@
                 <a:ea typeface="Calibri" pitchFamily="34" charset="-122"/>
                 <a:cs typeface="Calibri" pitchFamily="34" charset="-120"/>
               </a:rPr>
-              <a:t>374 题</a:t>
+              <a:t>374 items</a:t>
             </a:r>
             <a:endParaRPr lang="en-US" sz="1300" dirty="0"/>
           </a:p>
@@ -5657,7 +5663,7 @@
                 <a:ea typeface="Calibri" pitchFamily="34" charset="-122"/>
                 <a:cs typeface="Calibri" pitchFamily="34" charset="-120"/>
               </a:rPr>
-              <a:t>所需表项不在证据里</a:t>
+              <a:t>needed entries were not</a:t>
             </a:r>
             <a:endParaRPr lang="en-US" sz="1300" dirty="0"/>
           </a:p>
@@ -5699,7 +5705,7 @@
                 <a:ea typeface="Calibri" pitchFamily="34" charset="-122"/>
                 <a:cs typeface="Calibri" pitchFamily="34" charset="-120"/>
               </a:rPr>
-              <a:t>A0′ 的证据是刻意给到超过任何 arm 买得起的量：2000 次查询揭示 4913 条 unary 里的 2551 条、70k tokens 的上下文、不限思考、claude-opus-4-8、$19.94。它把给它的东西用得几乎完美，自己推不出任何东西。</a:t>
+              <a:t>A0′'s evidence was deliberately more generous than any arm could buy: 2000 queries revealing 2551 of 4913 unary entries, 70k tokens of context, unlimited thinking, claude-opus-4-8, $19.94 in total. It uses what it is told almost perfectly and infers almost nothing.</a:t>
             </a:r>
             <a:endParaRPr lang="en-US" sz="1350" dirty="0"/>
           </a:p>
@@ -5768,7 +5774,7 @@
                 <a:ea typeface="Calibri" pitchFamily="34" charset="-122"/>
                 <a:cs typeface="Calibri" pitchFamily="34" charset="-120"/>
               </a:rPr>
-              <a:t>H1 的强形式成立：</a:t>
+              <a:t>H1 holds in its strong form: </a:t>
             </a:r>
             <a:pPr indent="0" marL="0">
               <a:lnSpc>
@@ -5785,7 +5791,7 @@
                 <a:ea typeface="Calibri" pitchFamily="34" charset="-122"/>
                 <a:cs typeface="Calibri" pitchFamily="34" charset="-120"/>
               </a:rPr>
-              <a:t>weights 的优势是 learning-algorithmic，不是经济性。不是「前沿模型每题重读一遍证据太贵」，是重读也没有用 —— 梯度下降够得着的某种结构，in-context learning 够不着。</a:t>
+              <a:t>the weights advantage is learning-algorithmic, not economic. It is not that the frontier cannot afford to re-read the evidence per query — re-reading does not help. Some structure gradient descent reaches and in-context learning does not.</a:t>
             </a:r>
             <a:endParaRPr lang="en-US" sz="1400" dirty="0"/>
           </a:p>
@@ -5827,7 +5833,7 @@
                 <a:ea typeface="Calibri" pitchFamily="34" charset="-122"/>
                 <a:cs typeface="Calibri" pitchFamily="34" charset="-120"/>
               </a:rPr>
-              <a:t>两个要留着的细节：depth 分片上 A0′ 的 headroom 是 −0.018，查表次数最多的那一片，它比完全不知道表还差。另外证据不是它自己挑的（见第 8 页）。</a:t>
+              <a:t>Two details worth keeping: on depth — the split with the most lookups per item — A0′'s headroom is −0.018, below what knowing zero table entries gets you. And it did not choose its own evidence (page 8).</a:t>
             </a:r>
             <a:endParaRPr lang="en-US" sz="1200" dirty="0"/>
           </a:p>
@@ -5976,7 +5982,7 @@
                 <a:ea typeface="Cambria" pitchFamily="34" charset="-122"/>
                 <a:cs typeface="Cambria" pitchFamily="34" charset="-120"/>
               </a:rPr>
-              <a:t>监督衰减得比外推快 —— 可测带 [0.248, 0.498]</a:t>
+              <a:t>Supervision decays faster than extrapolation</a:t>
             </a:r>
             <a:endParaRPr lang="en-US" sz="3000" dirty="0"/>
           </a:p>
@@ -6007,19 +6013,22 @@
         <p:spPr>
           <a:xfrm>
             <a:off x="548640" y="5559552"/>
-            <a:ext cx="6858000" cy="502920"/>
-          </a:xfrm>
-          <a:prstGeom prst="rect">
-            <a:avLst/>
-          </a:prstGeom>
-          <a:noFill/>
-          <a:ln/>
-        </p:spPr>
-        <p:txBody>
-          <a:bodyPr wrap="square" lIns="0" tIns="0" rIns="0" bIns="0" rtlCol="0" anchor="ctr"/>
-          <a:lstStyle/>
-          <a:p>
-            <a:pPr indent="0" marL="0">
+            <a:ext cx="6858000" cy="548640"/>
+          </a:xfrm>
+          <a:prstGeom prst="rect">
+            <a:avLst/>
+          </a:prstGeom>
+          <a:noFill/>
+          <a:ln/>
+        </p:spPr>
+        <p:txBody>
+          <a:bodyPr wrap="square" lIns="0" tIns="0" rIns="0" bIns="0" rtlCol="0" anchor="ctr"/>
+          <a:lstStyle/>
+          <a:p>
+            <a:pPr indent="0" marL="0">
+              <a:lnSpc>
+                <a:spcPct val="115000"/>
+              </a:lnSpc>
               <a:buNone/>
             </a:pPr>
             <a:r>
@@ -6031,7 +6040,7 @@
                 <a:ea typeface="Calibri" pitchFamily="34" charset="-122"/>
                 <a:cs typeface="Calibri" pitchFamily="34" charset="-120"/>
               </a:rPr>
-              <a:t>横轴：训练时见过的表项比例（非线性刻度，六个测量点）—— 98 / 246 / 491 / 1228 / 2456 / 4422 条，共 4913 条</a:t>
+              <a:t>Share of table entries seen in training (non-linear scale, six measured points) — 98 / 246 / 491 / 1228 / 2456 / 4422 of 4913. The measurable band an arm operates in is [0.248, 0.498].</a:t>
             </a:r>
             <a:endParaRPr lang="en-US" sz="1050" dirty="0"/>
           </a:p>
@@ -6070,7 +6079,7 @@
                 <a:ea typeface="Calibri" pitchFamily="34" charset="-122"/>
                 <a:cs typeface="Calibri" pitchFamily="34" charset="-120"/>
               </a:rPr>
-              <a:t>2% 也还在外推</a:t>
+              <a:t>2% still extrapolates</a:t>
             </a:r>
             <a:endParaRPr lang="en-US" sz="1350" dirty="0"/>
           </a:p>
@@ -6112,7 +6121,7 @@
                 <a:ea typeface="Calibri" pitchFamily="34" charset="-122"/>
                 <a:cs typeface="Calibri" pitchFamily="34" charset="-120"/>
               </a:rPr>
-              <a:t>98 条表项 —— 只占表的 2% —— 在从没见过的题上仍拿到 0.147。前沿模型手里握着 2551 条，是 0.016。</a:t>
+              <a:t>98 entries — two percent of the table — still score 0.147 on items never shown. The frontier, holding 2551 of them in context, scores 0.016.</a:t>
             </a:r>
             <a:endParaRPr lang="en-US" sz="1150" dirty="0"/>
           </a:p>
@@ -6151,7 +6160,7 @@
                 <a:ea typeface="Calibri" pitchFamily="34" charset="-122"/>
                 <a:cs typeface="Calibri" pitchFamily="34" charset="-120"/>
               </a:rPr>
-              <a:t>瓶颈不是容量</a:t>
+              <a:t>Capacity is never the constraint</a:t>
             </a:r>
             <a:endParaRPr lang="en-US" sz="1350" dirty="0"/>
           </a:p>
@@ -6193,7 +6202,7 @@
                 <a:ea typeface="Calibri" pitchFamily="34" charset="-122"/>
                 <a:cs typeface="Calibri" pitchFamily="34" charset="-120"/>
               </a:rPr>
-              <a:t>每个点上 fit 都是 1.000：见过的它全记得。限制自始至终是泛化。</a:t>
+              <a:t>fit is 1.000 at every point: whatever it has seen, it retains perfectly. The limit is generalisation, all the way down.</a:t>
             </a:r>
             <a:endParaRPr lang="en-US" sz="1150" dirty="0"/>
           </a:p>
@@ -6232,7 +6241,7 @@
                 <a:ea typeface="Calibri" pitchFamily="34" charset="-122"/>
                 <a:cs typeface="Calibri" pitchFamily="34" charset="-120"/>
               </a:rPr>
-              <a:t>binary 对这个旋钮完全不敏感</a:t>
+              <a:t>binary is inert to this knob</a:t>
             </a:r>
             <a:endParaRPr lang="en-US" sz="1350" dirty="0"/>
           </a:p>
@@ -6274,7 +6283,7 @@
                 <a:ea typeface="Calibri" pitchFamily="34" charset="-122"/>
                 <a:cs typeface="Calibri" pitchFamily="34" charset="-120"/>
               </a:rPr>
-              <a:t>24M 条，任何设置都等于「几乎没见过」，所以曲线的形状是 unary 给的。</a:t>
+              <a:t>24M entries means every setting is "almost nothing seen", so the curve's shape is set by unary alone.</a:t>
             </a:r>
             <a:endParaRPr lang="en-US" sz="1150" dirty="0"/>
           </a:p>
@@ -6313,7 +6322,7 @@
                 <a:ea typeface="Calibri" pitchFamily="34" charset="-122"/>
                 <a:cs typeface="Calibri" pitchFamily="34" charset="-120"/>
               </a:rPr>
-              <a:t>噪声先量了再读</a:t>
+              <a:t>Noise measured before reading it</a:t>
             </a:r>
             <a:endParaRPr lang="en-US" sz="1350" dirty="0"/>
           </a:p>
@@ -6355,7 +6364,7 @@
                 <a:ea typeface="Calibri" pitchFamily="34" charset="-122"/>
                 <a:cs typeface="Calibri" pitchFamily="34" charset="-120"/>
               </a:rPr>
-              <a:t>同配置重跑，reach 差 ±0.04。别把小差读成信号。</a:t>
+              <a:t>Identical config, rerun: ±0.04 on reach. Do not read gaps that size as signal.</a:t>
             </a:r>
             <a:endParaRPr lang="en-US" sz="1150" dirty="0"/>
           </a:p>
@@ -6465,7 +6474,7 @@
                 <a:ea typeface="Courier New" pitchFamily="34" charset="-122"/>
                 <a:cs typeface="Courier New" pitchFamily="34" charset="-120"/>
               </a:rPr>
-              <a:t>STATE  ·  数据层已冻结 2026-08-31</a:t>
+              <a:t>STATE  ·  data layer frozen 2026-08-31</a:t>
             </a:r>
             <a:endParaRPr lang="en-US" sz="1100" dirty="0"/>
           </a:p>
@@ -6504,7 +6513,7 @@
                 <a:ea typeface="Cambria" pitchFamily="34" charset="-122"/>
                 <a:cs typeface="Cambria" pitchFamily="34" charset="-120"/>
               </a:rPr>
-              <a:t>工程状态：地基已经封住，评测层还在动</a:t>
+              <a:t>The foundation is sealed, evaluation still moves</a:t>
             </a:r>
             <a:endParaRPr lang="en-US" sz="3000" dirty="0"/>
           </a:p>
@@ -6562,7 +6571,7 @@
               <a:buNone/>
             </a:pPr>
             <a:r>
-              <a:rPr lang="en-US" sz="1350" dirty="0">
+              <a:rPr lang="en-US" sz="1250" dirty="0">
                 <a:solidFill>
                   <a:srgbClr val="3A4E9E"/>
                 </a:solidFill>
@@ -6572,7 +6581,7 @@
               </a:rPr>
               <a:t>138 passed</a:t>
             </a:r>
-            <a:endParaRPr lang="en-US" sz="1350" dirty="0"/>
+            <a:endParaRPr lang="en-US" sz="1250" dirty="0"/>
           </a:p>
         </p:txBody>
       </p:sp>
@@ -6612,7 +6621,7 @@
                 <a:ea typeface="Calibri" pitchFamily="34" charset="-122"/>
                 <a:cs typeface="Calibri" pitchFamily="34" charset="-120"/>
               </a:rPr>
-              <a:t>全量测试绿，含 test_infer.py。每次提交前必须绿。</a:t>
+              <a:t>Full suite green, test_infer.py included. Green before every commit.</a:t>
             </a:r>
             <a:endParaRPr lang="en-US" sz="1150" dirty="0"/>
           </a:p>
@@ -6670,7 +6679,7 @@
               <a:buNone/>
             </a:pPr>
             <a:r>
-              <a:rPr lang="en-US" sz="1350" dirty="0">
+              <a:rPr lang="en-US" sz="1250" dirty="0">
                 <a:solidFill>
                   <a:srgbClr val="3A4E9E"/>
                 </a:solidFill>
@@ -6678,9 +6687,9 @@
                 <a:ea typeface="Courier New" pitchFamily="34" charset="-122"/>
                 <a:cs typeface="Courier New" pitchFamily="34" charset="-120"/>
               </a:rPr>
-              <a:t>glyph/data/ 已隔离</a:t>
-            </a:r>
-            <a:endParaRPr lang="en-US" sz="1350" dirty="0"/>
+              <a:t>glyph/data/ isolated</a:t>
+            </a:r>
+            <a:endParaRPr lang="en-US" sz="1250" dirty="0"/>
           </a:p>
         </p:txBody>
       </p:sp>
@@ -6720,7 +6729,7 @@
                 <a:ea typeface="Calibri" pitchFamily="34" charset="-122"/>
                 <a:cs typeface="Calibri" pitchFamily="34" charset="-120"/>
               </a:rPr>
-              <a:t>七个模块搬进数据层，依赖单向；10 项边界测试用 AST 扫描守着这条线，T2 能整块把生成器搬走。</a:t>
+              <a:t>Seven modules moved into the data layer, dependencies one-way; 10 boundary tests hold the line with an AST scan, so T2 can lift the generator out whole.</a:t>
             </a:r>
             <a:endParaRPr lang="en-US" sz="1150" dirty="0"/>
           </a:p>
@@ -6778,7 +6787,7 @@
               <a:buNone/>
             </a:pPr>
             <a:r>
-              <a:rPr lang="en-US" sz="1350" dirty="0">
+              <a:rPr lang="en-US" sz="1250" dirty="0">
                 <a:solidFill>
                   <a:srgbClr val="3A4E9E"/>
                 </a:solidFill>
@@ -6786,9 +6795,9 @@
                 <a:ea typeface="Courier New" pitchFamily="34" charset="-122"/>
                 <a:cs typeface="Courier New" pitchFamily="34" charset="-120"/>
               </a:rPr>
-              <a:t>ledger 是唯一入口</a:t>
-            </a:r>
-            <a:endParaRPr lang="en-US" sz="1350" dirty="0"/>
+              <a:t>the ledger is the only entry</a:t>
+            </a:r>
+            <a:endParaRPr lang="en-US" sz="1250" dirty="0"/>
           </a:p>
         </p:txBody>
       </p:sp>
@@ -6828,7 +6837,7 @@
                 <a:ea typeface="Calibri" pitchFamily="34" charset="-122"/>
                 <a:cs typeface="Calibri" pitchFamily="34" charset="-120"/>
               </a:rPr>
-              <a:t>任何消耗算力的东西都走 charge。绕过一次，crossover 的数字就没意义了。</a:t>
+              <a:t>Anything that consumes compute goes through charge. One bypass and the crossover figure is meaningless.</a:t>
             </a:r>
             <a:endParaRPr lang="en-US" sz="1150" dirty="0"/>
           </a:p>
@@ -6886,7 +6895,7 @@
               <a:buNone/>
             </a:pPr>
             <a:r>
-              <a:rPr lang="en-US" sz="1350" dirty="0">
+              <a:rPr lang="en-US" sz="1250" dirty="0">
                 <a:solidFill>
                   <a:srgbClr val="3A4E9E"/>
                 </a:solidFill>
@@ -6894,9 +6903,9 @@
                 <a:ea typeface="Courier New" pitchFamily="34" charset="-122"/>
                 <a:cs typeface="Courier New" pitchFamily="34" charset="-120"/>
               </a:rPr>
-              <a:t>tool layer</a:t>
-            </a:r>
-            <a:endParaRPr lang="en-US" sz="1350" dirty="0"/>
+              <a:t>the tool layer</a:t>
+            </a:r>
+            <a:endParaRPr lang="en-US" sz="1250" dirty="0"/>
           </a:p>
         </p:txBody>
       </p:sp>
@@ -6936,7 +6945,7 @@
                 <a:ea typeface="Calibri" pitchFamily="34" charset="-122"/>
                 <a:cs typeface="Calibri" pitchFamily="34" charset="-120"/>
               </a:rPr>
-              <a:t>声明与分配分离，单一作答路径；agent 的自估被测量而不是被藏起来。</a:t>
+              <a:t>Declaration separated from allocation, one answering path; the agent's self-estimate is measured rather than hidden.</a:t>
             </a:r>
             <a:endParaRPr lang="en-US" sz="1150" dirty="0"/>
           </a:p>
@@ -6994,7 +7003,7 @@
               <a:buNone/>
             </a:pPr>
             <a:r>
-              <a:rPr lang="en-US" sz="1350" dirty="0">
+              <a:rPr lang="en-US" sz="1250" dirty="0">
                 <a:solidFill>
                   <a:srgbClr val="3A4E9E"/>
                 </a:solidFill>
@@ -7002,9 +7011,9 @@
                 <a:ea typeface="Courier New" pitchFamily="34" charset="-122"/>
                 <a:cs typeface="Courier New" pitchFamily="34" charset="-120"/>
               </a:rPr>
-              <a:t>每次打分都带 ceiling</a:t>
-            </a:r>
-            <a:endParaRPr lang="en-US" sz="1350" dirty="0"/>
+              <a:t>ceilings ship with every score</a:t>
+            </a:r>
+            <a:endParaRPr lang="en-US" sz="1250" dirty="0"/>
           </a:p>
         </p:txBody>
       </p:sp>
@@ -7044,7 +7053,7 @@
                 <a:ea typeface="Calibri" pitchFamily="34" charset="-122"/>
                 <a:cs typeface="Calibri" pitchFamily="34" charset="-120"/>
               </a:rPr>
-              <a:t>两个 ceiling 加 headroom 随每个分片一起出，tail 也终于有了自己的 ceiling。</a:t>
+              <a:t>Both ceilings plus headroom on every scored subset — tail finally has one of its own.</a:t>
             </a:r>
             <a:endParaRPr lang="en-US" sz="1150" dirty="0"/>
           </a:p>
@@ -7102,7 +7111,7 @@
               <a:buNone/>
             </a:pPr>
             <a:r>
-              <a:rPr lang="en-US" sz="1350" dirty="0">
+              <a:rPr lang="en-US" sz="1250" dirty="0">
                 <a:solidFill>
                   <a:srgbClr val="3A4E9E"/>
                 </a:solidFill>
@@ -7110,9 +7119,9 @@
                 <a:ea typeface="Courier New" pitchFamily="34" charset="-122"/>
                 <a:cs typeface="Courier New" pitchFamily="34" charset="-120"/>
               </a:rPr>
-              <a:t>自检 #1 #2 #3 #5 #6 通过</a:t>
-            </a:r>
-            <a:endParaRPr lang="en-US" sz="1350" dirty="0"/>
+              <a:t>self-checks 1 2 3 5 6 pass</a:t>
+            </a:r>
+            <a:endParaRPr lang="en-US" sz="1250" dirty="0"/>
           </a:p>
         </p:txBody>
       </p:sp>
@@ -7152,7 +7161,7 @@
                 <a:ea typeface="Calibri" pitchFamily="34" charset="-122"/>
                 <a:cs typeface="Calibri" pitchFamily="34" charset="-120"/>
               </a:rPr>
-              <a:t>#5 capacity：fit 1.000 / reach 0.710，该 check 要抓的失败没有发生。#4 hiddenness 需重跑。</a:t>
+              <a:t>#5 capacity: fit 1.000, reach 0.710 — the failure it exists to catch did not happen. #4 hiddenness must be rerun.</a:t>
             </a:r>
             <a:endParaRPr lang="en-US" sz="1150" dirty="0"/>
           </a:p>
@@ -7167,7 +7176,7 @@
         <p:spPr>
           <a:xfrm>
             <a:off x="640080" y="5486400"/>
-            <a:ext cx="1554480" cy="310896"/>
+            <a:ext cx="2148840" cy="310896"/>
           </a:xfrm>
           <a:prstGeom prst="rect">
             <a:avLst/>
@@ -7191,7 +7200,7 @@
                 <a:ea typeface="Calibri" pitchFamily="34" charset="-122"/>
                 <a:cs typeface="Calibri" pitchFamily="34" charset="-120"/>
               </a:rPr>
-              <a:t>已定、不再重开：</a:t>
+              <a:t>Settled, not reopened:</a:t>
             </a:r>
             <a:endParaRPr lang="en-US" sz="1200" dirty="0"/>
           </a:p>
@@ -7205,8 +7214,8 @@
         </p:nvSpPr>
         <p:spPr>
           <a:xfrm>
-            <a:off x="2148840" y="5486400"/>
-            <a:ext cx="1773936" cy="310896"/>
+            <a:off x="2862072" y="5486400"/>
+            <a:ext cx="2103120" cy="310896"/>
           </a:xfrm>
           <a:prstGeom prst="roundRect">
             <a:avLst>
@@ -7232,8 +7241,8 @@
         </p:nvSpPr>
         <p:spPr>
           <a:xfrm>
-            <a:off x="2148840" y="5486400"/>
-            <a:ext cx="1773936" cy="310896"/>
+            <a:off x="2862072" y="5486400"/>
+            <a:ext cx="2103120" cy="310896"/>
           </a:xfrm>
           <a:prstGeom prst="rect">
             <a:avLst/>
@@ -7271,8 +7280,8 @@
         </p:nvSpPr>
         <p:spPr>
           <a:xfrm>
-            <a:off x="4032504" y="5486400"/>
-            <a:ext cx="1773936" cy="310896"/>
+            <a:off x="5056632" y="5486400"/>
+            <a:ext cx="2103120" cy="310896"/>
           </a:xfrm>
           <a:prstGeom prst="roundRect">
             <a:avLst>
@@ -7298,8 +7307,8 @@
         </p:nvSpPr>
         <p:spPr>
           <a:xfrm>
-            <a:off x="4032504" y="5486400"/>
-            <a:ext cx="1773936" cy="310896"/>
+            <a:off x="5056632" y="5486400"/>
+            <a:ext cx="2103120" cy="310896"/>
           </a:xfrm>
           <a:prstGeom prst="rect">
             <a:avLst/>
@@ -7337,8 +7346,8 @@
         </p:nvSpPr>
         <p:spPr>
           <a:xfrm>
-            <a:off x="5916168" y="5486400"/>
-            <a:ext cx="1773936" cy="310896"/>
+            <a:off x="7251192" y="5486400"/>
+            <a:ext cx="2103120" cy="310896"/>
           </a:xfrm>
           <a:prstGeom prst="roundRect">
             <a:avLst>
@@ -7364,8 +7373,8 @@
         </p:nvSpPr>
         <p:spPr>
           <a:xfrm>
-            <a:off x="5916168" y="5486400"/>
-            <a:ext cx="1773936" cy="310896"/>
+            <a:off x="7251192" y="5486400"/>
+            <a:ext cx="2103120" cy="310896"/>
           </a:xfrm>
           <a:prstGeom prst="rect">
             <a:avLst/>
@@ -7403,8 +7412,8 @@
         </p:nvSpPr>
         <p:spPr>
           <a:xfrm>
-            <a:off x="7799832" y="5486400"/>
-            <a:ext cx="1773936" cy="310896"/>
+            <a:off x="9445752" y="5486400"/>
+            <a:ext cx="2103120" cy="310896"/>
           </a:xfrm>
           <a:prstGeom prst="roundRect">
             <a:avLst>
@@ -7430,8 +7439,8 @@
         </p:nvSpPr>
         <p:spPr>
           <a:xfrm>
-            <a:off x="7799832" y="5486400"/>
-            <a:ext cx="1773936" cy="310896"/>
+            <a:off x="9445752" y="5486400"/>
+            <a:ext cx="2103120" cy="310896"/>
           </a:xfrm>
           <a:prstGeom prst="rect">
             <a:avLst/>
@@ -7455,73 +7464,7 @@
                 <a:ea typeface="Courier New" pitchFamily="34" charset="-122"/>
                 <a:cs typeface="Courier New" pitchFamily="34" charset="-120"/>
               </a:rPr>
-              <a:t>n_structural(pi_low) = 5</a:t>
-            </a:r>
-            <a:endParaRPr lang="en-US" sz="1100" dirty="0"/>
-          </a:p>
-        </p:txBody>
-      </p:sp>
-      <p:sp>
-        <p:nvSpPr>
-          <p:cNvPr id="32" name="Shape 30"/>
-          <p:cNvSpPr/>
-          <p:nvPr/>
-        </p:nvSpPr>
-        <p:spPr>
-          <a:xfrm>
-            <a:off x="9683496" y="5486400"/>
-            <a:ext cx="1773936" cy="310896"/>
-          </a:xfrm>
-          <a:prstGeom prst="roundRect">
-            <a:avLst>
-              <a:gd name="adj" fmla="val 17647"/>
-            </a:avLst>
-          </a:prstGeom>
-          <a:solidFill>
-            <a:srgbClr val="EAECF1"/>
-          </a:solidFill>
-          <a:ln w="6350">
-            <a:solidFill>
-              <a:srgbClr val="EAECF1"/>
-            </a:solidFill>
-            <a:prstDash val="solid"/>
-          </a:ln>
-        </p:spPr>
-      </p:sp>
-      <p:sp>
-        <p:nvSpPr>
-          <p:cNvPr id="33" name="Text 31"/>
-          <p:cNvSpPr txBox="1"/>
-          <p:nvPr/>
-        </p:nvSpPr>
-        <p:spPr>
-          <a:xfrm>
-            <a:off x="9683496" y="5486400"/>
-            <a:ext cx="1773936" cy="310896"/>
-          </a:xfrm>
-          <a:prstGeom prst="rect">
-            <a:avLst/>
-          </a:prstGeom>
-          <a:noFill/>
-          <a:ln/>
-        </p:spPr>
-        <p:txBody>
-          <a:bodyPr wrap="square" lIns="0" tIns="0" rIns="0" bIns="0" rtlCol="0" anchor="ctr"/>
-          <a:lstStyle/>
-          <a:p>
-            <a:pPr algn="ctr" indent="0" marL="0">
-              <a:buNone/>
-            </a:pPr>
-            <a:r>
-              <a:rPr lang="en-US" sz="1100" dirty="0">
-                <a:solidFill>
-                  <a:srgbClr val="3A4E9E"/>
-                </a:solidFill>
-                <a:latin typeface="Courier New" pitchFamily="34" charset="0"/>
-                <a:ea typeface="Courier New" pitchFamily="34" charset="-122"/>
-                <a:cs typeface="Courier New" pitchFamily="34" charset="-120"/>
-              </a:rPr>
-              <a:t>无 floor 分片</a:t>
+              <a:t>no floor split</a:t>
             </a:r>
             <a:endParaRPr lang="en-US" sz="1100" dirty="0"/>
           </a:p>
@@ -7670,7 +7613,7 @@
                 <a:ea typeface="Cambria" pitchFamily="34" charset="-122"/>
                 <a:cs typeface="Cambria" pitchFamily="34" charset="-120"/>
               </a:rPr>
-              <a:t>还没定的，和接下来的顺序</a:t>
+              <a:t>What is open, and the order of what comes next</a:t>
             </a:r>
             <a:endParaRPr lang="en-US" sz="3000" dirty="0"/>
           </a:p>
@@ -7684,8 +7627,8 @@
         </p:nvSpPr>
         <p:spPr>
           <a:xfrm>
-            <a:off x="640080" y="1536192"/>
-            <a:ext cx="777240" cy="274320"/>
+            <a:off x="640080" y="1481328"/>
+            <a:ext cx="822960" cy="274320"/>
           </a:xfrm>
           <a:prstGeom prst="rect">
             <a:avLst/>
@@ -7723,8 +7666,8 @@
         </p:nvSpPr>
         <p:spPr>
           <a:xfrm>
-            <a:off x="1463040" y="1499616"/>
-            <a:ext cx="5120640" cy="310896"/>
+            <a:off x="1508760" y="1444752"/>
+            <a:ext cx="5257800" cy="310896"/>
           </a:xfrm>
           <a:prstGeom prst="rect">
             <a:avLst/>
@@ -7748,7 +7691,7 @@
                 <a:ea typeface="Calibri" pitchFamily="34" charset="-122"/>
                 <a:cs typeface="Calibri" pitchFamily="34" charset="-120"/>
               </a:rPr>
-              <a:t>π 目前只在 iid 上测</a:t>
+              <a:t>π is still measured on iid only</a:t>
             </a:r>
             <a:endParaRPr lang="en-US" sz="1400" dirty="0"/>
           </a:p>
@@ -7762,8 +7705,8 @@
         </p:nvSpPr>
         <p:spPr>
           <a:xfrm>
-            <a:off x="1463040" y="1819656"/>
-            <a:ext cx="5120640" cy="603504"/>
+            <a:off x="1508760" y="1764792"/>
+            <a:ext cx="5257800" cy="658368"/>
           </a:xfrm>
           <a:prstGeom prst="rect">
             <a:avLst/>
@@ -7790,7 +7733,7 @@
                 <a:ea typeface="Calibri" pitchFamily="34" charset="-122"/>
                 <a:cs typeface="Calibri" pitchFamily="34" charset="-120"/>
               </a:rPr>
-              <a:t>pi_low 上「只测 iid」和分层测最大差 0.166，因为那里 skeleton 只在 comp 上有贡献。改采样等于改基线，而基线一改，此前所有 π 全部作废。</a:t>
+              <a:t>On pi_low, iid-only and stratified π differ by as much as 0.166. Changing the sample is close to changing the baselines, and that invalidates every π measured so far.</a:t>
             </a:r>
             <a:endParaRPr lang="en-US" sz="1150" dirty="0"/>
           </a:p>
@@ -7804,8 +7747,8 @@
         </p:nvSpPr>
         <p:spPr>
           <a:xfrm>
-            <a:off x="640080" y="2724912"/>
-            <a:ext cx="777240" cy="274320"/>
+            <a:off x="640080" y="2670048"/>
+            <a:ext cx="822960" cy="274320"/>
           </a:xfrm>
           <a:prstGeom prst="rect">
             <a:avLst/>
@@ -7843,8 +7786,8 @@
         </p:nvSpPr>
         <p:spPr>
           <a:xfrm>
-            <a:off x="1463040" y="2688336"/>
-            <a:ext cx="5120640" cy="310896"/>
+            <a:off x="1508760" y="2633472"/>
+            <a:ext cx="5257800" cy="310896"/>
           </a:xfrm>
           <a:prstGeom prst="rect">
             <a:avLst/>
@@ -7868,7 +7811,7 @@
                 <a:ea typeface="Calibri" pitchFamily="34" charset="-122"/>
                 <a:cs typeface="Calibri" pitchFamily="34" charset="-120"/>
               </a:rPr>
-              <a:t>A0′ 的证据不是它自己挑的</a:t>
+              <a:t>A0′ did not choose its own evidence</a:t>
             </a:r>
             <a:endParaRPr lang="en-US" sz="1400" dirty="0"/>
           </a:p>
@@ -7882,8 +7825,8 @@
         </p:nvSpPr>
         <p:spPr>
           <a:xfrm>
-            <a:off x="1463040" y="3008376"/>
-            <a:ext cx="5120640" cy="603504"/>
+            <a:off x="1508760" y="2953512"/>
+            <a:ext cx="5257800" cy="658368"/>
           </a:xfrm>
           <a:prstGeom prst="rect">
             <a:avLst/>
@@ -7910,7 +7853,7 @@
                 <a:ea typeface="Calibri" pitchFamily="34" charset="-122"/>
                 <a:cs typeface="Calibri" pitchFamily="34" charset="-120"/>
               </a:rPr>
-              <a:t>2000 条查询是脚本抽的，真实 agent 会自适应地探。口子窄 —— 52% 的表都给了，外推还是 1.6% —— 但存在。</a:t>
+              <a:t>The 2000 queries were drawn by a script; a real agent probes adaptively. The opening is narrow — 52% of the table was handed over, extrapolation still 1.6% — but it is real.</a:t>
             </a:r>
             <a:endParaRPr lang="en-US" sz="1150" dirty="0"/>
           </a:p>
@@ -7924,8 +7867,8 @@
         </p:nvSpPr>
         <p:spPr>
           <a:xfrm>
-            <a:off x="640080" y="3913632"/>
-            <a:ext cx="777240" cy="274320"/>
+            <a:off x="640080" y="3858768"/>
+            <a:ext cx="822960" cy="274320"/>
           </a:xfrm>
           <a:prstGeom prst="rect">
             <a:avLst/>
@@ -7963,8 +7906,8 @@
         </p:nvSpPr>
         <p:spPr>
           <a:xfrm>
-            <a:off x="1463040" y="3877056"/>
-            <a:ext cx="5120640" cy="310896"/>
+            <a:off x="1508760" y="3822192"/>
+            <a:ext cx="5257800" cy="310896"/>
           </a:xfrm>
           <a:prstGeom prst="rect">
             <a:avLst/>
@@ -7988,7 +7931,7 @@
                 <a:ea typeface="Calibri" pitchFamily="34" charset="-122"/>
                 <a:cs typeface="Calibri" pitchFamily="34" charset="-120"/>
               </a:rPr>
-              <a:t>E0 四臂已经作废两次</a:t>
+              <a:t>E0's four arms, invalidated twice</a:t>
             </a:r>
             <a:endParaRPr lang="en-US" sz="1400" dirty="0"/>
           </a:p>
@@ -8002,8 +7945,8 @@
         </p:nvSpPr>
         <p:spPr>
           <a:xfrm>
-            <a:off x="1463040" y="4197096"/>
-            <a:ext cx="5120640" cy="603504"/>
+            <a:off x="1508760" y="4142232"/>
+            <a:ext cx="5257800" cy="658368"/>
           </a:xfrm>
           <a:prstGeom prst="rect">
             <a:avLst/>
@@ -8030,7 +7973,7 @@
                 <a:ea typeface="Calibri" pitchFamily="34" charset="-122"/>
                 <a:cs typeface="Calibri" pitchFamily="34" charset="-120"/>
               </a:rPr>
-              <a:t>preset 改过一次，held-pair 改过一次；n=200 时差异本来也分辨不出。数据层冻结之前不重跑。</a:t>
+              <a:t>Once by the preset change, once by the held-pair change; at n = 200 the differences were never resolvable anyway. Do not rerun until the data layer is frozen.</a:t>
             </a:r>
             <a:endParaRPr lang="en-US" sz="1150" dirty="0"/>
           </a:p>
@@ -8044,8 +7987,8 @@
         </p:nvSpPr>
         <p:spPr>
           <a:xfrm>
-            <a:off x="640080" y="5102352"/>
-            <a:ext cx="777240" cy="274320"/>
+            <a:off x="640080" y="5047488"/>
+            <a:ext cx="822960" cy="274320"/>
           </a:xfrm>
           <a:prstGeom prst="rect">
             <a:avLst/>
@@ -8083,8 +8026,8 @@
         </p:nvSpPr>
         <p:spPr>
           <a:xfrm>
-            <a:off x="1463040" y="5065776"/>
-            <a:ext cx="5120640" cy="310896"/>
+            <a:off x="1508760" y="5010912"/>
+            <a:ext cx="5257800" cy="310896"/>
           </a:xfrm>
           <a:prstGeom prst="rect">
             <a:avLst/>
@@ -8108,7 +8051,7 @@
                 <a:ea typeface="Calibri" pitchFamily="34" charset="-122"/>
                 <a:cs typeface="Calibri" pitchFamily="34" charset="-120"/>
               </a:rPr>
-              <a:t>两件没写的代码</a:t>
+              <a:t>Two things not written</a:t>
             </a:r>
             <a:endParaRPr lang="en-US" sz="1400" dirty="0"/>
           </a:p>
@@ -8122,8 +8065,8 @@
         </p:nvSpPr>
         <p:spPr>
           <a:xfrm>
-            <a:off x="1463040" y="5385816"/>
-            <a:ext cx="5120640" cy="603504"/>
+            <a:off x="1508760" y="5330952"/>
+            <a:ext cx="5257800" cy="658368"/>
           </a:xfrm>
           <a:prstGeom prst="rect">
             <a:avLst/>
@@ -8150,7 +8093,7 @@
                 <a:ea typeface="Calibri" pitchFamily="34" charset="-122"/>
                 <a:cs typeface="Calibri" pitchFamily="34" charset="-120"/>
               </a:rPr>
-              <a:t>prompt caching 计划里有、从没实现，八次运行零命中；T2 零行，而 Glyph 自己撑不起摊销 —— 准备成本约是服务的 100 倍。</a:t>
+              <a:t>Prompt caching: in the plan, never implemented, zero cache hits across eight runs. T2: zero lines, and Glyph cannot carry amortisation — preparing costs ~100× serving.</a:t>
             </a:r>
             <a:endParaRPr lang="en-US" sz="1150" dirty="0"/>
           </a:p>
@@ -8164,12 +8107,12 @@
         </p:nvSpPr>
         <p:spPr>
           <a:xfrm>
-            <a:off x="7040880" y="1572768"/>
-            <a:ext cx="4507992" cy="4160520"/>
+            <a:off x="7040880" y="1481328"/>
+            <a:ext cx="4507992" cy="4206240"/>
           </a:xfrm>
           <a:prstGeom prst="roundRect">
             <a:avLst>
-              <a:gd name="adj" fmla="val 659"/>
+              <a:gd name="adj" fmla="val 652"/>
             </a:avLst>
           </a:prstGeom>
           <a:solidFill>
@@ -8191,7 +8134,7 @@
         </p:nvSpPr>
         <p:spPr>
           <a:xfrm>
-            <a:off x="7315200" y="1783080"/>
+            <a:off x="7315200" y="1691640"/>
             <a:ext cx="3931920" cy="365760"/>
           </a:xfrm>
           <a:prstGeom prst="rect">
@@ -8216,7 +8159,7 @@
                 <a:ea typeface="Cambria" pitchFamily="34" charset="-122"/>
                 <a:cs typeface="Cambria" pitchFamily="34" charset="-120"/>
               </a:rPr>
-              <a:t>下一步的顺序</a:t>
+              <a:t>The order from here</a:t>
             </a:r>
             <a:endParaRPr lang="en-US" sz="1800" dirty="0"/>
           </a:p>
@@ -8230,7 +8173,7 @@
         </p:nvSpPr>
         <p:spPr>
           <a:xfrm>
-            <a:off x="7315200" y="2286000"/>
+            <a:off x="7315200" y="2212848"/>
             <a:ext cx="274320" cy="274320"/>
           </a:xfrm>
           <a:prstGeom prst="rect">
@@ -8269,7 +8212,7 @@
         </p:nvSpPr>
         <p:spPr>
           <a:xfrm>
-            <a:off x="7635240" y="2258568"/>
+            <a:off x="7635240" y="2185416"/>
             <a:ext cx="3611880" cy="274320"/>
           </a:xfrm>
           <a:prstGeom prst="rect">
@@ -8294,7 +8237,7 @@
                 <a:ea typeface="Calibri" pitchFamily="34" charset="-122"/>
                 <a:cs typeface="Calibri" pitchFamily="34" charset="-120"/>
               </a:rPr>
-              <a:t>重跑自检 #4 hiddenness</a:t>
+              <a:t>Rerun self-check #4</a:t>
             </a:r>
             <a:endParaRPr lang="en-US" sz="1250" dirty="0"/>
           </a:p>
@@ -8308,8 +8251,8 @@
         </p:nvSpPr>
         <p:spPr>
           <a:xfrm>
-            <a:off x="7635240" y="2542032"/>
-            <a:ext cx="3611880" cy="548640"/>
+            <a:off x="7635240" y="2468880"/>
+            <a:ext cx="3611880" cy="566928"/>
           </a:xfrm>
           <a:prstGeom prst="rect">
             <a:avLst/>
@@ -8336,7 +8279,7 @@
                 <a:ea typeface="Calibri" pitchFamily="34" charset="-122"/>
                 <a:cs typeface="Calibri" pitchFamily="34" charset="-120"/>
               </a:rPr>
-              <a:t>每个 preset 都变了，pi_high 尤其是另一个任务了。约 110 分钟，花 teacher 调用。</a:t>
+              <a:t>Hiddenness. Every preset changed; pi_high is a different task now. ~110 min, costs teacher calls.</a:t>
             </a:r>
             <a:endParaRPr lang="en-US" sz="1050" dirty="0"/>
           </a:p>
@@ -8350,7 +8293,7 @@
         </p:nvSpPr>
         <p:spPr>
           <a:xfrm>
-            <a:off x="7315200" y="3154680"/>
+            <a:off x="7315200" y="3081528"/>
             <a:ext cx="274320" cy="274320"/>
           </a:xfrm>
           <a:prstGeom prst="rect">
@@ -8389,7 +8332,7 @@
         </p:nvSpPr>
         <p:spPr>
           <a:xfrm>
-            <a:off x="7635240" y="3127248"/>
+            <a:off x="7635240" y="3054096"/>
             <a:ext cx="3611880" cy="274320"/>
           </a:xfrm>
           <a:prstGeom prst="rect">
@@ -8414,7 +8357,7 @@
                 <a:ea typeface="Calibri" pitchFamily="34" charset="-122"/>
                 <a:cs typeface="Calibri" pitchFamily="34" charset="-120"/>
               </a:rPr>
-              <a:t>定 #9 / #4：评测规模与报告口径</a:t>
+              <a:t>Settle #9 / #4</a:t>
             </a:r>
             <a:endParaRPr lang="en-US" sz="1250" dirty="0"/>
           </a:p>
@@ -8428,8 +8371,8 @@
         </p:nvSpPr>
         <p:spPr>
           <a:xfrm>
-            <a:off x="7635240" y="3410712"/>
-            <a:ext cx="3611880" cy="548640"/>
+            <a:off x="7635240" y="3337560"/>
+            <a:ext cx="3611880" cy="566928"/>
           </a:xfrm>
           <a:prstGeom prst="rect">
             <a:avLst/>
@@ -8456,7 +8399,7 @@
                 <a:ea typeface="Calibri" pitchFamily="34" charset="-122"/>
                 <a:cs typeface="Calibri" pitchFamily="34" charset="-120"/>
               </a:rPr>
-              <a:t>arm 之间只差 1–3 个点，n 不够就什么也分辨不出。</a:t>
+              <a:t>Evaluation size and how scores are reported. Arms differ by 1–3 points; too small an n resolves nothing.</a:t>
             </a:r>
             <a:endParaRPr lang="en-US" sz="1050" dirty="0"/>
           </a:p>
@@ -8470,7 +8413,7 @@
         </p:nvSpPr>
         <p:spPr>
           <a:xfrm>
-            <a:off x="7315200" y="4023360"/>
+            <a:off x="7315200" y="3950208"/>
             <a:ext cx="274320" cy="274320"/>
           </a:xfrm>
           <a:prstGeom prst="rect">
@@ -8509,7 +8452,7 @@
         </p:nvSpPr>
         <p:spPr>
           <a:xfrm>
-            <a:off x="7635240" y="3995928"/>
+            <a:off x="7635240" y="3922776"/>
             <a:ext cx="3611880" cy="274320"/>
           </a:xfrm>
           <a:prstGeom prst="rect">
@@ -8534,7 +8477,7 @@
                 <a:ea typeface="Calibri" pitchFamily="34" charset="-122"/>
                 <a:cs typeface="Calibri" pitchFamily="34" charset="-120"/>
               </a:rPr>
-              <a:t>E0 四臂：最小闭环</a:t>
+              <a:t>E0's four arms</a:t>
             </a:r>
             <a:endParaRPr lang="en-US" sz="1250" dirty="0"/>
           </a:p>
@@ -8548,8 +8491,8 @@
         </p:nvSpPr>
         <p:spPr>
           <a:xfrm>
-            <a:off x="7635240" y="4279392"/>
-            <a:ext cx="3611880" cy="548640"/>
+            <a:off x="7635240" y="4206240"/>
+            <a:ext cx="3611880" cy="566928"/>
           </a:xfrm>
           <a:prstGeom prst="rect">
             <a:avLst/>
@@ -8576,7 +8519,7 @@
                 <a:ea typeface="Calibri" pitchFamily="34" charset="-122"/>
                 <a:cs typeface="Calibri" pitchFamily="34" charset="-120"/>
               </a:rPr>
-              <a:t>agent 查询 → 封存 → 打分 → 一个数。A2 / A4 / A6，一次跑完而不是三次。</a:t>
+              <a:t>The minimum closed loop: agent queries → seal → evaluate → one score. A2 / A4 / A6, one pass not three.</a:t>
             </a:r>
             <a:endParaRPr lang="en-US" sz="1050" dirty="0"/>
           </a:p>
@@ -8590,7 +8533,7 @@
         </p:nvSpPr>
         <p:spPr>
           <a:xfrm>
-            <a:off x="7315200" y="4892040"/>
+            <a:off x="7315200" y="4818888"/>
             <a:ext cx="274320" cy="274320"/>
           </a:xfrm>
           <a:prstGeom prst="rect">
@@ -8629,7 +8572,7 @@
         </p:nvSpPr>
         <p:spPr>
           <a:xfrm>
-            <a:off x="7635240" y="4864608"/>
+            <a:off x="7635240" y="4791456"/>
             <a:ext cx="3611880" cy="274320"/>
           </a:xfrm>
           <a:prstGeom prst="rect">
@@ -8654,7 +8597,7 @@
                 <a:ea typeface="Calibri" pitchFamily="34" charset="-122"/>
                 <a:cs typeface="Calibri" pitchFamily="34" charset="-120"/>
               </a:rPr>
-              <a:t>#26 相图</a:t>
+              <a:t>#26 the phase diagram</a:t>
             </a:r>
             <a:endParaRPr lang="en-US" sz="1250" dirty="0"/>
           </a:p>
@@ -8668,8 +8611,8 @@
         </p:nvSpPr>
         <p:spPr>
           <a:xfrm>
-            <a:off x="7635240" y="5148072"/>
-            <a:ext cx="3611880" cy="548640"/>
+            <a:off x="7635240" y="5074920"/>
+            <a:ext cx="3611880" cy="566928"/>
           </a:xfrm>
           <a:prstGeom prst="rect">
             <a:avLst/>
@@ -8696,7 +8639,7 @@
                 <a:ea typeface="Calibri" pitchFamily="34" charset="-122"/>
                 <a:cs typeface="Calibri" pitchFamily="34" charset="-120"/>
               </a:rPr>
-              <a:t>横轴用 measured_pi()。注意 worker 的 5400s 超时会偏向「少做事」的 agent。</a:t>
+              <a:t>Axis is measured_pi(). The worker's 5400 s timeout biases toward agents doing less.</a:t>
             </a:r>
             <a:endParaRPr lang="en-US" sz="1050" dirty="0"/>
           </a:p>
@@ -8710,8 +8653,8 @@
         </p:nvSpPr>
         <p:spPr>
           <a:xfrm>
-            <a:off x="640080" y="6053328"/>
-            <a:ext cx="5943600" cy="320040"/>
+            <a:off x="640080" y="5989320"/>
+            <a:ext cx="6126480" cy="365760"/>
           </a:xfrm>
           <a:prstGeom prst="rect">
             <a:avLst/>
@@ -8735,7 +8678,7 @@
                 <a:ea typeface="Calibri" pitchFamily="34" charset="-122"/>
                 <a:cs typeface="Calibri" pitchFamily="34" charset="-120"/>
               </a:rPr>
-              <a:t>arm 的结果还没有发：早先那一轮被数据层的改动作废了，harness 上还有两处不对称没定。</a:t>
+              <a:t>Arm results are not published yet: the earlier sweep is invalidated by the data-layer changes, and two harness asymmetries are still open decisions.</a:t>
             </a:r>
             <a:endParaRPr lang="en-US" sz="1100" dirty="0"/>
           </a:p>

</xml_diff>